<commit_message>
Week 02 lecture .pptx: two text fixes (slides 7 and 24)
Slide 7: "away from the origin O" (it said "away from 0"); slide 5 calls
the point O. Slide 24: minus sign in "minimise −cᵀx" (it was a hyphen).
The PDF needs re-exporting in PowerPoint.

Co-Authored-By: Claude Opus 5.5 <noreply@anthropic.com>
Claude-Session: https://claude.ai/code/session_01HKaqmtPGTZRp5nsgEMNNDk
[skip ci]
</commit_message>
<xml_diff>
--- a/content/Lectures/Semester 1/Week 02 - Linear Programming 1/5 Source Files/Week 2 - Linear Programming 1.pptx
+++ b/content/Lectures/Semester 1/Week 02 - Linear Programming 1/5 Source Files/Week 2 - Linear Programming 1.pptx
@@ -19014,7 +19014,7 @@
                 </a:pPr>
                 <a:r>
                   <a:rPr lang="en-GB" dirty="0"/>
-                  <a:t>minimise     -</a:t>
+                  <a:t>minimise     −</a:t>
                 </a:r>
                 <a14:m>
                   <m:oMath xmlns:m="http://schemas.openxmlformats.org/officeDocument/2006/math">
@@ -23592,7 +23592,7 @@
                 </a:r>
                 <a:r>
                   <a:rPr lang="en-GB" dirty="0"/>
-                  <a:t> profit line away from </a:t>
+                  <a:t> profit line away from the origin </a:t>
                 </a:r>
                 <a14:m>
                   <m:oMath xmlns:m="http://schemas.openxmlformats.org/officeDocument/2006/math">
@@ -23600,7 +23600,7 @@
                       <a:rPr lang="en-GB" b="0" i="1" smtClean="0">
                         <a:latin typeface="Cambria Math" panose="02040503050406030204" pitchFamily="18" charset="0"/>
                       </a:rPr>
-                      <m:t>0</m:t>
+                      <m:t>𝑂</m:t>
                     </m:r>
                   </m:oMath>
                 </a14:m>

</xml_diff>